<commit_message>
chore(preview): OR.PA outputs regeneres
</commit_message>
<xml_diff>
--- a/preview/OR.PA/OR.PA_pitchbook.pptx
+++ b/preview/OR.PA/OR.PA_pitchbook.pptx
@@ -6138,7 +6138,7 @@
                 </a:solidFill>
                 <a:latin typeface="Calibri"/>
               </a:rPr>
-              <a:t>Les marges brutes progressent de 72.4% en 2022 à 74.3% en 2025 grâce à l'optimisation des coûts matières premières et à la hausse des prix (+2.5% en moyenne annuelle). Les marges EBITDA et nettes se stabilisent autour de 24.3% et 14.5% respectivement, reflétant un levier opérationnel maîtrisé et un mix produits favorable. Cette stabilité suggère une durabilité des marges à moyen terme.</a:t>
+              <a:t>Les marges brute (74.3%), EBITDA (24.3%) et nette (13.9%) affichent une stabilité remarquable depuis 2022, avec une légère compression nette en 2025 due à des coûts logistiques et marketing accrus. Cette résilience s'explique par le levier opérationnel, un mix produit premium et une politique de pricing agressive. Pour l'investisseur, cela implique une durabilité des marges et un potentiel de re-rating si la compression nette se résorbe.</a:t>
             </a:r>
           </a:p>
         </p:txBody>
@@ -7622,7 +7622,7 @@
                           </a:solidFill>
                           <a:latin typeface="Calibri"/>
                         </a:rPr>
-                        <a:t>340 EUR</a:t>
+                        <a:t>330 EUR</a:t>
                       </a:r>
                     </a:p>
                   </a:txBody>
@@ -7693,7 +7693,7 @@
                           </a:solidFill>
                           <a:latin typeface="Calibri"/>
                         </a:rPr>
-                        <a:t>-3,1 %</a:t>
+                        <a:t>-5,9 %</a:t>
                       </a:r>
                     </a:p>
                   </a:txBody>
@@ -9480,7 +9480,7 @@
                 </a:solidFill>
                 <a:latin typeface="Calibri"/>
               </a:rPr>
-              <a:t>Avec un WACC de 8.5% et une TGR de 2.0%, le prix implicite DCF est de 375 EUR, soit un upside de 7% vs le cours actuel. La prime actuelle semble refléter une croissance déjà anticipée, mais les catalyseurs asiatiques pourraient justifier une revalorisation.</a:t>
+              <a:t>Avec un WACC de 8.5% et une TGR de 2.0%, le prix implicite DCF est de 395 EUR, soit un upside de 12.6% vs cours actuel. La prime de croissance est partiellement pricee, mais les catalyseurs (Chine, innovation) pourraient justifier une revalorisation. Un risque d'execution sur les coûts logistiques ou une dégradation en Chine pourrait limiter l'upside.</a:t>
             </a:r>
           </a:p>
         </p:txBody>
@@ -10544,7 +10544,7 @@
                           </a:solidFill>
                           <a:latin typeface="Calibri"/>
                         </a:rPr>
-                        <a:t>42,5</a:t>
+                        <a:t>35,2</a:t>
                       </a:r>
                     </a:p>
                   </a:txBody>
@@ -10567,7 +10567,7 @@
                           </a:solidFill>
                           <a:latin typeface="Calibri"/>
                         </a:rPr>
-                        <a:t>15,2x</a:t>
+                        <a:t>15,8x</a:t>
                       </a:r>
                     </a:p>
                   </a:txBody>
@@ -10590,7 +10590,7 @@
                           </a:solidFill>
                           <a:latin typeface="Calibri"/>
                         </a:rPr>
-                        <a:t>3,8x</a:t>
+                        <a:t>3,1x</a:t>
                       </a:r>
                     </a:p>
                   </a:txBody>
@@ -10636,7 +10636,7 @@
                           </a:solidFill>
                           <a:latin typeface="Calibri"/>
                         </a:rPr>
-                        <a:t>76,1 %</a:t>
+                        <a:t>72,0 %</a:t>
                       </a:r>
                     </a:p>
                   </a:txBody>
@@ -10659,7 +10659,7 @@
                           </a:solidFill>
                           <a:latin typeface="Calibri"/>
                         </a:rPr>
-                        <a:t>22,5 %</a:t>
+                        <a:t>22,0 %</a:t>
                       </a:r>
                     </a:p>
                   </a:txBody>
@@ -10684,7 +10684,7 @@
                           </a:solidFill>
                           <a:latin typeface="Calibri"/>
                         </a:rPr>
-                        <a:t>Unilever Beauty &amp; Personal Car</a:t>
+                        <a:t>Shiseido</a:t>
                       </a:r>
                     </a:p>
                   </a:txBody>
@@ -10707,7 +10707,7 @@
                           </a:solidFill>
                           <a:latin typeface="Calibri"/>
                         </a:rPr>
-                        <a:t>ULVR.L</a:t>
+                        <a:t>4911.T</a:t>
                       </a:r>
                     </a:p>
                   </a:txBody>
@@ -10730,7 +10730,7 @@
                           </a:solidFill>
                           <a:latin typeface="Calibri"/>
                         </a:rPr>
-                        <a:t>110,2</a:t>
+                        <a:t>5,8</a:t>
                       </a:r>
                     </a:p>
                   </a:txBody>
@@ -10753,7 +10753,7 @@
                           </a:solidFill>
                           <a:latin typeface="Calibri"/>
                         </a:rPr>
-                        <a:t>13,8x</a:t>
+                        <a:t>8,2x</a:t>
                       </a:r>
                     </a:p>
                   </a:txBody>
@@ -10776,7 +10776,7 @@
                           </a:solidFill>
                           <a:latin typeface="Calibri"/>
                         </a:rPr>
-                        <a:t>2,9x</a:t>
+                        <a:t>1,2x</a:t>
                       </a:r>
                     </a:p>
                   </a:txBody>
@@ -10799,7 +10799,7 @@
                           </a:solidFill>
                           <a:latin typeface="Calibri"/>
                         </a:rPr>
-                        <a:t>22,4x</a:t>
+                        <a:t>12,5x</a:t>
                       </a:r>
                     </a:p>
                   </a:txBody>
@@ -10822,7 +10822,7 @@
                           </a:solidFill>
                           <a:latin typeface="Calibri"/>
                         </a:rPr>
-                        <a:t>58,2 %</a:t>
+                        <a:t>68,0 %</a:t>
                       </a:r>
                     </a:p>
                   </a:txBody>
@@ -10845,7 +10845,7 @@
                           </a:solidFill>
                           <a:latin typeface="Calibri"/>
                         </a:rPr>
-                        <a:t>20,1 %</a:t>
+                        <a:t>18,0 %</a:t>
                       </a:r>
                     </a:p>
                   </a:txBody>
@@ -10870,7 +10870,7 @@
                           </a:solidFill>
                           <a:latin typeface="Calibri"/>
                         </a:rPr>
-                        <a:t>Shiseido</a:t>
+                        <a:t>Unilever (Beauty &amp; Personal Ca</a:t>
                       </a:r>
                     </a:p>
                   </a:txBody>
@@ -10893,7 +10893,7 @@
                           </a:solidFill>
                           <a:latin typeface="Calibri"/>
                         </a:rPr>
-                        <a:t>4911.T</a:t>
+                        <a:t>ULVR.L</a:t>
                       </a:r>
                     </a:p>
                   </a:txBody>
@@ -10916,7 +10916,7 @@
                           </a:solidFill>
                           <a:latin typeface="Calibri"/>
                         </a:rPr>
-                        <a:t>8,9</a:t>
+                        <a:t>120,0</a:t>
                       </a:r>
                     </a:p>
                   </a:txBody>
@@ -10939,7 +10939,7 @@
                           </a:solidFill>
                           <a:latin typeface="Calibri"/>
                         </a:rPr>
-                        <a:t>10,5x</a:t>
+                        <a:t>14,2x</a:t>
                       </a:r>
                     </a:p>
                   </a:txBody>
@@ -10962,7 +10962,7 @@
                           </a:solidFill>
                           <a:latin typeface="Calibri"/>
                         </a:rPr>
-                        <a:t>2,1x</a:t>
+                        <a:t>2,8x</a:t>
                       </a:r>
                     </a:p>
                   </a:txBody>
@@ -10985,7 +10985,7 @@
                           </a:solidFill>
                           <a:latin typeface="Calibri"/>
                         </a:rPr>
-                        <a:t>28,7x</a:t>
+                        <a:t>22,1x</a:t>
                       </a:r>
                     </a:p>
                   </a:txBody>
@@ -11008,7 +11008,7 @@
                           </a:solidFill>
                           <a:latin typeface="Calibri"/>
                         </a:rPr>
-                        <a:t>71,2 %</a:t>
+                        <a:t>55,0 %</a:t>
                       </a:r>
                     </a:p>
                   </a:txBody>
@@ -11031,7 +11031,7 @@
                           </a:solidFill>
                           <a:latin typeface="Calibri"/>
                         </a:rPr>
-                        <a:t>18,9 %</a:t>
+                        <a:t>20,0 %</a:t>
                       </a:r>
                     </a:p>
                   </a:txBody>
@@ -11056,7 +11056,7 @@
                           </a:solidFill>
                           <a:latin typeface="Calibri"/>
                         </a:rPr>
-                        <a:t>Beiersdorf</a:t>
+                        <a:t>Procter &amp; Gamble (Beauty)</a:t>
                       </a:r>
                     </a:p>
                   </a:txBody>
@@ -11079,7 +11079,7 @@
                           </a:solidFill>
                           <a:latin typeface="Calibri"/>
                         </a:rPr>
-                        <a:t>BEI.DE</a:t>
+                        <a:t>PG</a:t>
                       </a:r>
                     </a:p>
                   </a:txBody>
@@ -11102,7 +11102,7 @@
                           </a:solidFill>
                           <a:latin typeface="Calibri"/>
                         </a:rPr>
-                        <a:t>28,7</a:t>
+                        <a:t>380,0</a:t>
                       </a:r>
                     </a:p>
                   </a:txBody>
@@ -11148,7 +11148,7 @@
                           </a:solidFill>
                           <a:latin typeface="Calibri"/>
                         </a:rPr>
-                        <a:t>3,2x</a:t>
+                        <a:t>3,5x</a:t>
                       </a:r>
                     </a:p>
                   </a:txBody>
@@ -11171,7 +11171,7 @@
                           </a:solidFill>
                           <a:latin typeface="Calibri"/>
                         </a:rPr>
-                        <a:t>—</a:t>
+                        <a:t>28,5x</a:t>
                       </a:r>
                     </a:p>
                   </a:txBody>
@@ -11194,7 +11194,7 @@
                           </a:solidFill>
                           <a:latin typeface="Calibri"/>
                         </a:rPr>
-                        <a:t>67,8 %</a:t>
+                        <a:t>52,0 %</a:t>
                       </a:r>
                     </a:p>
                   </a:txBody>
@@ -11217,7 +11217,7 @@
                           </a:solidFill>
                           <a:latin typeface="Calibri"/>
                         </a:rPr>
-                        <a:t>21,3 %</a:t>
+                        <a:t>23,0 %</a:t>
                       </a:r>
                     </a:p>
                   </a:txBody>
@@ -11242,7 +11242,7 @@
                           </a:solidFill>
                           <a:latin typeface="Calibri"/>
                         </a:rPr>
-                        <a:t>Procter &amp; Gamble Beauty</a:t>
+                        <a:t>Beiersdorf</a:t>
                       </a:r>
                     </a:p>
                   </a:txBody>
@@ -11265,7 +11265,7 @@
                           </a:solidFill>
                           <a:latin typeface="Calibri"/>
                         </a:rPr>
-                        <a:t>PG</a:t>
+                        <a:t>BEI.DE</a:t>
                       </a:r>
                     </a:p>
                   </a:txBody>
@@ -11288,7 +11288,7 @@
                           </a:solidFill>
                           <a:latin typeface="Calibri"/>
                         </a:rPr>
-                        <a:t>380,5</a:t>
+                        <a:t>28,5</a:t>
                       </a:r>
                     </a:p>
                   </a:txBody>
@@ -11311,7 +11311,7 @@
                           </a:solidFill>
                           <a:latin typeface="Calibri"/>
                         </a:rPr>
-                        <a:t>18,7x</a:t>
+                        <a:t>13,5x</a:t>
                       </a:r>
                     </a:p>
                   </a:txBody>
@@ -11334,7 +11334,7 @@
                           </a:solidFill>
                           <a:latin typeface="Calibri"/>
                         </a:rPr>
-                        <a:t>4,1x</a:t>
+                        <a:t>2,9x</a:t>
                       </a:r>
                     </a:p>
                   </a:txBody>
@@ -11357,7 +11357,7 @@
                           </a:solidFill>
                           <a:latin typeface="Calibri"/>
                         </a:rPr>
-                        <a:t>—</a:t>
+                        <a:t>25,3x</a:t>
                       </a:r>
                     </a:p>
                   </a:txBody>
@@ -11380,7 +11380,7 @@
                           </a:solidFill>
                           <a:latin typeface="Calibri"/>
                         </a:rPr>
-                        <a:t>52,3 %</a:t>
+                        <a:t>65,0 %</a:t>
                       </a:r>
                     </a:p>
                   </a:txBody>
@@ -11403,7 +11403,7 @@
                           </a:solidFill>
                           <a:latin typeface="Calibri"/>
                         </a:rPr>
-                        <a:t>23,9 %</a:t>
+                        <a:t>19,0 %</a:t>
                       </a:r>
                     </a:p>
                   </a:txBody>
@@ -11497,7 +11497,7 @@
                           </a:solidFill>
                           <a:latin typeface="Calibri"/>
                         </a:rPr>
-                        <a:t>15,2x</a:t>
+                        <a:t>14,2x</a:t>
                       </a:r>
                     </a:p>
                   </a:txBody>
@@ -11520,7 +11520,7 @@
                           </a:solidFill>
                           <a:latin typeface="Calibri"/>
                         </a:rPr>
-                        <a:t>3,2x</a:t>
+                        <a:t>2,9x</a:t>
                       </a:r>
                     </a:p>
                   </a:txBody>
@@ -11543,7 +11543,7 @@
                           </a:solidFill>
                           <a:latin typeface="Calibri"/>
                         </a:rPr>
-                        <a:t>28,7x</a:t>
+                        <a:t>25,3x</a:t>
                       </a:r>
                     </a:p>
                   </a:txBody>
@@ -11566,7 +11566,7 @@
                           </a:solidFill>
                           <a:latin typeface="Calibri"/>
                         </a:rPr>
-                        <a:t>67,8 %</a:t>
+                        <a:t>65,0 %</a:t>
                       </a:r>
                     </a:p>
                   </a:txBody>
@@ -11589,7 +11589,7 @@
                           </a:solidFill>
                           <a:latin typeface="Calibri"/>
                         </a:rPr>
-                        <a:t>21,3 %</a:t>
+                        <a:t>20,0 %</a:t>
                       </a:r>
                     </a:p>
                   </a:txBody>
@@ -11634,7 +11634,7 @@
                 </a:solidFill>
                 <a:latin typeface="Calibri"/>
               </a:rPr>
-              <a:t>L'Oréal affiche un EV/EBITDA de 17.6x vs une médiane peers de 14.1x (+25%), et un P/E de 30.6x vs 24.5x (+25%). Cette prime est justifiée par une croissance organique supérieure (3.5-4% vs 2-3% peers) et une résilience des marges. Une convergence vers la médiane impliquerait un downside de 15%, peu probable sans choc sectoriel.</a:t>
+              <a:t>L'Oréal se négocie à 17.6x EV/EBITDA vs médiane peers à 16.8x (+5%), et à 30.6x P/E vs 28.5x (+7%). La prime reflète une croissance organique supérieure (+4.5% vs +3.2% peers) et des marges plus résilientes. Une convergence vers la médiane peers impliquerait un downside de 8-10%, tandis qu'une prime maintenue justifierait l'upside actuel.</a:t>
             </a:r>
           </a:p>
         </p:txBody>
@@ -12292,7 +12292,7 @@
                 </a:solidFill>
                 <a:latin typeface="Calibri"/>
               </a:rPr>
-              <a:t>Avec un WACC de 8.5% et une TGR de 2.0%, le prix implicite DCF est de 375 EUR, soit un upside de 7% vs le cours actuel. La prime actuelle semble refléter une croissance déjà anticipée, mais les catalyseurs asiatiques pourraient justifier une revalorisation.</a:t>
+              <a:t>Avec un WACC de 8.5% et une TGR de 2.0%, le prix implicite DCF est de 395 EUR, soit un upside de 12.6% vs cours actuel. La prime de croissance est partiellement pricee, mais les catalyseurs (Chine, innovation) pourraient justifier une revalorisation. Un risque d'execution sur les coûts logistiques ou une dégradation en Chine pourrait limiter l'upside.</a:t>
             </a:r>
           </a:p>
         </p:txBody>
@@ -13265,7 +13265,7 @@
                 </a:solidFill>
                 <a:latin typeface="Calibri"/>
               </a:rPr>
-              <a:t>Valorisation excessive</a:t>
+              <a:t>Prime de valorisation excessive</a:t>
             </a:r>
           </a:p>
         </p:txBody>
@@ -13300,7 +13300,7 @@
                 </a:solidFill>
                 <a:latin typeface="Calibri"/>
               </a:rPr>
-              <a:t>Le P/E de 30.56x est 50% supérieur à la moyenne sectorielle de 20.3x, reflétant une valorisation excessive pour un secteur mature comme les cosmétiques. Les marges nettes de 13.9% en 2025 supposent une maîtrise parfaite des coûts, alors que les pressions salariales en Europe (+4.5% en 2024) et la hausse des matières premières (+12% depuis 2022) menacent cette stabilité. L'EV/EBITDA à 17.55x ignore le risque de décote en cas de ralentissement des ventes premium, déjà…</a:t>
+              <a:t>Le P/E de 30.56x surpasse de 50% la moyenne sectorielle des cosmétiques (20.3x), reflétant une prime de valorisation déjà intégrée dans le cours actuel.</a:t>
             </a:r>
           </a:p>
         </p:txBody>
@@ -13421,7 +13421,7 @@
                 </a:solidFill>
                 <a:latin typeface="Calibri"/>
               </a:rPr>
-              <a:t>Dépendance produits clés</a:t>
+              <a:t>Risque prix-volume</a:t>
             </a:r>
           </a:p>
         </p:txBody>
@@ -13456,7 +13456,7 @@
                 </a:solidFill>
                 <a:latin typeface="Calibri"/>
               </a:rPr>
-              <a:t>L'Altman Z-score de 5.67 masque une dépendance critique aux marques phares : 60% du CA provient de 10 produits, dont 3 représentent 35% des marges. Une perte de part de marché sur un seul produit (ex : L'Oréal Paris) réduirait le ROE de 3 points, passant de 17.5% à 14.5%, un seuil critique pour les investisseurs. Les coûts R&amp;D (3.2% du CA) n'ont pas généré d'innovation disruptive depuis 2018, malgré un budget en hausse de 15%.</a:t>
+              <a:t>Les marges nettes de 13.9% stagnent depuis 2021 malgré des hausses de prix de 8% en 2023, signalant une érosion de pouvoir de fixation des prix.</a:t>
             </a:r>
           </a:p>
         </p:txBody>
@@ -13577,7 +13577,7 @@
                 </a:solidFill>
                 <a:latin typeface="Calibri"/>
               </a:rPr>
-              <a:t>Risque liquidité</a:t>
+              <a:t>Stagnation marges</a:t>
             </a:r>
           </a:p>
         </p:txBody>
@@ -13612,7 +13612,7 @@
                 </a:solidFill>
                 <a:latin typeface="Calibri"/>
               </a:rPr>
-              <a:t>Le NetDebt/EBITDA de 0.02x est artificiellement bas grâce à une trésorerie de 4.2 Md€, mais 68% est bloquée dans des filiales étrangères, limitant sa liquidité immédiate. Une crise géopolitique (ex : tensions USA-Chine) pourrait geler 2.8 Md€ de fonds, réduisant la capacité de réaction à 1.4x l'EBITDA, un niveau dangereux face à un concurrent comme Estée Lauder (0.8x).</a:t>
+              <a:t>La R&amp;D premium à 3.1% du CA (2023) n'a généré aucun blockbuster depuis 2019, remettant en cause son efficacité.</a:t>
             </a:r>
           </a:p>
         </p:txBody>
@@ -13826,7 +13826,7 @@
                           </a:solidFill>
                           <a:latin typeface="Calibri"/>
                         </a:rPr>
-                        <a:t>Ralentissement du PIB chinois &lt;4% en 2026</a:t>
+                        <a:t>Ralentissement économique en Chine de -3pp vs consensus 2026</a:t>
                       </a:r>
                     </a:p>
                   </a:txBody>
@@ -13897,7 +13897,7 @@
                           </a:solidFill>
                           <a:latin typeface="Calibri"/>
                         </a:rPr>
-                        <a:t>Interdiction des tests sur animaux en UE étendue à d'autres régions</a:t>
+                        <a:t>Pénétration accélérée de l'IA dans le maquillage (-5pp part de marché)</a:t>
                       </a:r>
                     </a:p>
                   </a:txBody>
@@ -13968,7 +13968,7 @@
                           </a:solidFill>
                           <a:latin typeface="Calibri"/>
                         </a:rPr>
-                        <a:t>Perte de parts de marché en Amérique du Nord &gt;3 points</a:t>
+                        <a:t>Échec du lancement de la gamme premium en Inde (CA &lt;100m EUR en 2026)</a:t>
                       </a:r>
                     </a:p>
                   </a:txBody>
@@ -14974,7 +14974,7 @@
                 </a:solidFill>
                 <a:latin typeface="Calibri"/>
               </a:rPr>
-              <a:t>Neutre +</a:t>
+              <a:t>Positif</a:t>
             </a:r>
           </a:p>
         </p:txBody>
@@ -15044,7 +15044,7 @@
                 </a:solidFill>
                 <a:latin typeface="Calibri"/>
               </a:rPr>
-              <a:t>Score agrege : +0,140</a:t>
+              <a:t>Score agrege : +0,280</a:t>
             </a:r>
           </a:p>
         </p:txBody>
@@ -15356,7 +15356,7 @@
                 </a:solidFill>
                 <a:latin typeface="Calibri"/>
               </a:rPr>
-              <a:t>48,0 %</a:t>
+              <a:t>46,0 %</a:t>
             </a:r>
           </a:p>
         </p:txBody>
@@ -15812,7 +15812,7 @@
                           </a:solidFill>
                           <a:latin typeface="Calibri"/>
                         </a:rPr>
-                        <a:t>6</a:t>
+                        <a:t>10</a:t>
                       </a:r>
                     </a:p>
                   </a:txBody>
@@ -15835,7 +15835,7 @@
                           </a:solidFill>
                           <a:latin typeface="Calibri"/>
                         </a:rPr>
-                        <a:t>+0,330</a:t>
+                        <a:t>+0,460</a:t>
                       </a:r>
                     </a:p>
                   </a:txBody>
@@ -15858,7 +15858,7 @@
                           </a:solidFill>
                           <a:latin typeface="Calibri"/>
                         </a:rPr>
-                        <a:t>Croissance Asie +12% en 2026 avec lancement de 50 nouveaux produits en Chine | +1.8Md EUR de revenus supplémentaires | Horizon 2026-2027</a:t>
+                        <a:t>Expansion en Chine : +15% CA organique en 2026 via digitalisation et lancements premium | Mécanisme : croissance volume + mix prix | Horizon : 12-18 mois</a:t>
                       </a:r>
                     </a:p>
                   </a:txBody>
@@ -15906,7 +15906,7 @@
                           </a:solidFill>
                           <a:latin typeface="Calibri"/>
                         </a:rPr>
-                        <a:t>11</a:t>
+                        <a:t>7</a:t>
                       </a:r>
                     </a:p>
                   </a:txBody>
@@ -15929,7 +15929,7 @@
                           </a:solidFill>
                           <a:latin typeface="Calibri"/>
                         </a:rPr>
-                        <a:t>+0,480</a:t>
+                        <a:t>+0,360</a:t>
                       </a:r>
                     </a:p>
                   </a:txBody>
@@ -16023,7 +16023,7 @@
                           </a:solidFill>
                           <a:latin typeface="Calibri"/>
                         </a:rPr>
-                        <a:t>+0,190</a:t>
+                        <a:t>+0,180</a:t>
                       </a:r>
                     </a:p>
                   </a:txBody>
@@ -16046,7 +16046,7 @@
                           </a:solidFill>
                           <a:latin typeface="Calibri"/>
                         </a:rPr>
-                        <a:t>Ralentissement économique en Chine -5% de croissance organique | Baisse des ventes premium de -8% | Horizon 2026-2027</a:t>
+                        <a:t>Ralentissement Chine : -3pp croissance CA organique si tensions géopolitiques | Mécanisme : pression sur le mix prix et volumes | Horizon : 6-12 mois, impact…</a:t>
                       </a:r>
                     </a:p>
                   </a:txBody>
@@ -16091,7 +16091,7 @@
                 </a:solidFill>
                 <a:latin typeface="Calibri"/>
               </a:rPr>
-              <a:t>La presse financière souligne une dynamique positive pour L'Oréal cette semaine, portée par des partenariats technologiques et des initiatives durables. Cependant, les incertitudes liées aux tensions commerciales et géopolitiques pèsent sur le sentiment global.</a:t>
+              <a:t>La presse financière souligne une dynamique positive pour L'Oréal cette semaine, portée par des partenariats technologiques et des initiatives durables. Cependant, les tensions commerciales et géopolitiques introduisent une note de prudence sur certains segments.</a:t>
             </a:r>
           </a:p>
         </p:txBody>
@@ -19029,7 +19029,7 @@
                 </a:solidFill>
                 <a:latin typeface="Calibri"/>
               </a:rPr>
-              <a:t>L'Oréal se négocie à une prime de 25% vs la médiane des pairs sur EV/EBITDA (17.6x vs 14.1x). Cette prime est justifiée par une croissance organique supérieure et une résilience des marges.</a:t>
+              <a:t>L'Oréal se négocie à 17.6x EV/EBITDA vs médiane peers à 16.8x, soit une prime de 5%. Le P/E de 30.6x reflète une croissance supérieure et une qualité d'actifs reconnue. La prime semble justifiée par la résilience des marges et la diversification géographique.</a:t>
             </a:r>
           </a:p>
         </p:txBody>
@@ -19359,7 +19359,7 @@
                 </a:solidFill>
                 <a:latin typeface="Calibri"/>
               </a:rPr>
-              <a:t>Prix cible base : 385 EUR  ·  Upside : +9,7 %  ·  Bear : 340 EUR (-3,1 %)  ·  Bull : 420 EUR (+19,7 %)</a:t>
+              <a:t>Prix cible base : 385 EUR  ·  Upside : +9,7 %  ·  Bear : 330 EUR (-5,9 %)  ·  Bull : 420 EUR (+19,7 %)</a:t>
             </a:r>
           </a:p>
         </p:txBody>
@@ -19515,7 +19515,7 @@
                 </a:solidFill>
                 <a:latin typeface="Calibri"/>
               </a:rPr>
-              <a:t>Leadership mondial</a:t>
+              <a:t>Leader mondial</a:t>
             </a:r>
           </a:p>
         </p:txBody>
@@ -19550,7 +19550,7 @@
                 </a:solidFill>
                 <a:latin typeface="Calibri"/>
               </a:rPr>
-              <a:t>L'Oréal devrait bénéficier d'une croissance organique de 3.5% en 2026 grâce à l'Asie (+12% en Chine) et aux innovations anti-âge</a:t>
+              <a:t>L'Oréal devrait bénéficier d'une croissance organique de 4.5% en 2026 grâce à l'expansion en Chine (+15% CA) et aux lancements de produits premiumisés</a:t>
             </a:r>
           </a:p>
         </p:txBody>
@@ -19628,7 +19628,7 @@
                 </a:solidFill>
                 <a:latin typeface="Calibri"/>
               </a:rPr>
-              <a:t>Marges premium</a:t>
+              <a:t>R&amp;D premium</a:t>
             </a:r>
           </a:p>
         </p:txBody>
@@ -19663,7 +19663,7 @@
                 </a:solidFill>
                 <a:latin typeface="Calibri"/>
               </a:rPr>
-              <a:t>Les marges EBITDA devraient se stabiliser à 24.5% en 2027 grâce à l'automatisation des usines et la réduction des coûts logistiques</a:t>
+              <a:t>La marge EBITDA devrait se stabiliser à 25.0% en 2027 via optimisation des coûts logistiques et mix produit favorable</a:t>
             </a:r>
           </a:p>
         </p:txBody>
@@ -19741,7 +19741,7 @@
                 </a:solidFill>
                 <a:latin typeface="Calibri"/>
               </a:rPr>
-              <a:t>Innovation R&amp;D</a:t>
+              <a:t>Levier opérationnel</a:t>
             </a:r>
           </a:p>
         </p:txBody>
@@ -19776,7 +19776,7 @@
                 </a:solidFill>
                 <a:latin typeface="Calibri"/>
               </a:rPr>
-              <a:t>Le groupe vise 20% de part de marché en Inde d'ici 2027, soit +3 points vs 2025.</a:t>
+              <a:t>Le ROIC de 20%+ et la trésorerie nette de 5.2mds EUR soutiennent une politique de dividende progressive (+5% annuel) et des rachats d'actions.</a:t>
             </a:r>
           </a:p>
         </p:txBody>
@@ -19932,7 +19932,7 @@
                 </a:solidFill>
                 <a:latin typeface="Calibri"/>
               </a:rPr>
-              <a:t>Dépendance Asie</a:t>
+              <a:t>Risque Chine</a:t>
             </a:r>
           </a:p>
         </p:txBody>
@@ -19967,7 +19967,7 @@
                 </a:solidFill>
                 <a:latin typeface="Calibri"/>
               </a:rPr>
-              <a:t>Ralentissement économique en Chine -5% de croissance organique | Baisse des ventes premium de -8% | Horizon 2026-2027</a:t>
+              <a:t>Ralentissement Chine : -3pp croissance CA organique si tensions géopolitiques | Mécanisme : pression sur le mix prix et volumes | Horizon : 6-12 mois, impact -8% CA</a:t>
             </a:r>
           </a:p>
         </p:txBody>
@@ -20045,7 +20045,7 @@
                 </a:solidFill>
                 <a:latin typeface="Calibri"/>
               </a:rPr>
-              <a:t>Concurrence Estée Lauder</a:t>
+              <a:t>Concurrence IA</a:t>
             </a:r>
           </a:p>
         </p:txBody>
@@ -20080,7 +20080,7 @@
                 </a:solidFill>
                 <a:latin typeface="Calibri"/>
               </a:rPr>
-              <a:t>Concurrence accrue d'Estée Lauder en Amérique du Nord | Perte de parts de marché de 2 points | Horizon 2026</a:t>
+              <a:t>Concurrence IA : perte de 5pp de part de marché en maquillage face à outils digitaux | Mécanisme : baisse prix et volumes | Horizon : 12-24 mois, impact -3% marge nette</a:t>
             </a:r>
           </a:p>
         </p:txBody>
@@ -20158,7 +20158,7 @@
                 </a:solidFill>
                 <a:latin typeface="Calibri"/>
               </a:rPr>
-              <a:t>Réglementation cosmétique</a:t>
+              <a:t>Pressions prix</a:t>
             </a:r>
           </a:p>
         </p:txBody>
@@ -20193,7 +20193,7 @@
                 </a:solidFill>
                 <a:latin typeface="Calibri"/>
               </a:rPr>
-              <a:t>Réglementation européenne sur les ingrédients +10% de coûts R&amp;D | Compression des marges de 150 bps | Horizon 2027</a:t>
+              <a:t>Pressions prix matières : +8% coût des ingrédients en 2026 non répercutable | Mécanisme : compression marges brute et EBITDA | Horizon : 12 mois, impact -150bps EBITDA</a:t>
             </a:r>
           </a:p>
         </p:txBody>
@@ -20470,7 +20470,7 @@
                 </a:solidFill>
                 <a:latin typeface="Calibri"/>
               </a:rPr>
-              <a:t>vs 15,2x médiane peers</a:t>
+              <a:t>vs 14,2x médiane peers</a:t>
             </a:r>
           </a:p>
         </p:txBody>
@@ -20973,7 +20973,7 @@
                 </a:solidFill>
                 <a:latin typeface="Calibri"/>
               </a:rPr>
-              <a:t>+0,140</a:t>
+              <a:t>+0,280</a:t>
             </a:r>
           </a:p>
         </p:txBody>
@@ -21043,7 +21043,7 @@
                 </a:solidFill>
                 <a:latin typeface="Calibri"/>
               </a:rPr>
-              <a:t>Neutre +  ·  20 articles</a:t>
+              <a:t>Positif  ·  20 articles</a:t>
             </a:r>
           </a:p>
         </p:txBody>
@@ -23672,7 +23672,7 @@
                 </a:solidFill>
                 <a:latin typeface="Calibri"/>
               </a:rPr>
-              <a:t>L'Oréal affiche une résilience opérationnelle remarquable avec des marges stables malgré un environnement macro difficile. La diversification géographique et segmentaire réduit la volatilité des revenus et soutient la croissance organique à 3-5% par an.</a:t>
+              <a:t>L'Oréal affiche une résilience opérationnelle remarquable avec des marges stables et une croissance organique soutenue. Le modèle premium diversifié et l'innovation continue renforcent sa position de leader mondial. La valorisation reste attractive malgré une prime modérée vs peers.</a:t>
             </a:r>
           </a:p>
         </p:txBody>
@@ -24715,7 +24715,7 @@
                 </a:solidFill>
                 <a:latin typeface="Calibri"/>
               </a:rPr>
-              <a:t>Dépendance Asie  ·  Concurrence Estée Lauder</a:t>
+              <a:t>Risque Chine  ·  Concurrence IA</a:t>
             </a:r>
           </a:p>
         </p:txBody>
@@ -25949,7 +25949,7 @@
                 </a:solidFill>
                 <a:latin typeface="Calibri"/>
               </a:rPr>
-              <a:t>L'Oréal S.A. est le leader mondial des produits cosmétiques avec une présence dans 150 pays. Positionné sur les segments premium, mass-market et dermo-cosmétique, le groupe mise sur l'innovation R&amp;D et le digital pour capter la demande asiatique et anti-âge. Ses avantages concurrentiels incluent une marque forte (Lancôme, Garnier), une chaîne de distribution intégrée et une efficacité logistique mondiale. L'entreprise articule son activité autour de deux segments stratégiques :</a:t>
+              <a:t>L'Oréal S.A. est le leader mondial des produits de beauté avec un portefeuille diversifié couvrant tous les segments (soin, maquillage, coiffure, parfums). Positionné sur le premium avec des marques comme Lancôme, L'Oréal Paris et Garnier, le groupe cible une clientèle mondiale via distribution sélective et mass-market. Ses avantages incluent une R&amp;D inégalée, un levier opérationnel exceptionnel et une résilience en période de crise grâce à la diversité géographique et segmentaire. L'entreprise articule son activité autour de deux segments stratégiques :</a:t>
             </a:r>
           </a:p>
         </p:txBody>
@@ -26041,7 +26041,7 @@
         <p:spPr>
           <a:xfrm>
             <a:off x="619200" y="2714400"/>
-            <a:ext cx="4338000" cy="396000"/>
+            <a:ext cx="4338000" cy="503999"/>
           </a:xfrm>
           <a:prstGeom prst="rect">
             <a:avLst/>
@@ -26062,7 +26062,7 @@
                 </a:solidFill>
                 <a:latin typeface="Calibri"/>
               </a:rPr>
-              <a:t>Segment mass-market (Garnier, Maybelline) avec modèle de revenus récurrents via distribution en grandes surfaces et e-commerce. Croissance tirée par l'Asie (+8% en 2025) et l'innovation produits (soins capillaires). Clients cibles : 18-45 ans en zones urbaines. Marges stables grâce à l'effet de scale sur les volumes.</a:t>
+              <a:t>Segment mass-market incluant L'Oréal Paris, Garnier et Maybelline, distribué via grandes surfaces et pharmacies. Modèle basé sur volume élevé et prix accessibles, avec croissance tirée par l'innovation produit et l'expansion en Asie. Clients cibles : consommateurs sensibles au prix avec demande croissante pour soins personnalisés. Moteurs : lancements de gammes premiumisées et stratégies digitales.</a:t>
             </a:r>
           </a:p>
         </p:txBody>
@@ -26075,7 +26075,7 @@
         </p:nvSpPr>
         <p:spPr>
           <a:xfrm>
-            <a:off x="503999" y="3193199"/>
+            <a:off x="503999" y="3301199"/>
             <a:ext cx="64800" cy="64800"/>
           </a:xfrm>
           <a:prstGeom prst="rect">
@@ -26118,7 +26118,7 @@
         </p:nvSpPr>
         <p:spPr>
           <a:xfrm>
-            <a:off x="619200" y="3150000"/>
+            <a:off x="619200" y="3257999"/>
             <a:ext cx="4338000" cy="165600"/>
           </a:xfrm>
           <a:prstGeom prst="rect">
@@ -26153,8 +26153,8 @@
         </p:nvSpPr>
         <p:spPr>
           <a:xfrm>
-            <a:off x="619200" y="3308400"/>
-            <a:ext cx="4338000" cy="396000"/>
+            <a:off x="619200" y="3416399"/>
+            <a:ext cx="4338000" cy="503999"/>
           </a:xfrm>
           <a:prstGeom prst="rect">
             <a:avLst/>
@@ -26175,7 +26175,7 @@
                 </a:solidFill>
                 <a:latin typeface="Calibri"/>
               </a:rPr>
-              <a:t>Segment B2B (L'Oréal Professionnel) avec revenus liés aux salons de coiffure et formations. Modèle basé sur la fidélisation des coiffeurs via produits haut de gamme et services digitaux. Croissance portée par l'Amérique du Nord (+5% en 2025) et l'innovation (coloration durable).</a:t>
+              <a:t>Segment B2B pour salons de coiffure avec marques comme Redken et Kerastase. Modèle basé sur partenariats avec coiffeurs et salons, avec revenus récurrents via consommables et équipements. Clients cibles : professionnels exigeants recherchant performance et durabilité. Moteurs : innovation en soins capillaires et expansion en Amérique latine.</a:t>
             </a:r>
           </a:p>
         </p:txBody>
@@ -27554,7 +27554,7 @@
                 </a:solidFill>
                 <a:latin typeface="Calibri"/>
               </a:rPr>
-              <a:t>38%</a:t>
+              <a:t>45%</a:t>
             </a:r>
           </a:p>
         </p:txBody>
@@ -27702,7 +27702,7 @@
                 </a:solidFill>
                 <a:latin typeface="Calibri"/>
               </a:rPr>
-              <a:t>Segment mass-market (Garnier, Maybelline) avec modèle de revenus récurrents via distribution en grandes surfaces et e-commerce. Croissance tirée par l'Asie (+8% en 2025) et l'innovation produits (soins capillaires). Clients cibles : 18-45 ans en zones urbaines. Marges stables grâce à l'effet de scale sur les volumes.</a:t>
+              <a:t>Segment mass-market incluant L'Oréal Paris, Garnier et Maybelline, distribué via grandes surfaces et pharmacies. Modèle basé sur volume élevé et prix accessibles, avec croissance tirée par l'innovation produit et l'expansion en Asie. Clients cibles : consommateurs sensibles au prix avec demande croissante pour soins personnalisés. Moteurs : lancements de gammes premiumisées et stratégies digitales.</a:t>
             </a:r>
           </a:p>
         </p:txBody>
@@ -27823,7 +27823,7 @@
                 </a:solidFill>
                 <a:latin typeface="Calibri"/>
               </a:rPr>
-              <a:t>12%</a:t>
+              <a:t>19%</a:t>
             </a:r>
           </a:p>
         </p:txBody>
@@ -27971,7 +27971,7 @@
                 </a:solidFill>
                 <a:latin typeface="Calibri"/>
               </a:rPr>
-              <a:t>Segment B2B (L'Oréal Professionnel) avec revenus liés aux salons de coiffure et formations. Modèle basé sur la fidélisation des coiffeurs via produits haut de gamme et services digitaux. Croissance portée par l'Amérique du Nord (+5% en 2025) et l'innovation (coloration durable).</a:t>
+              <a:t>Segment B2B pour salons de coiffure avec marques comme Redken et Kerastase. Modèle basé sur partenariats avec coiffeurs et salons, avec revenus récurrents via consommables et équipements. Clients cibles : professionnels exigeants recherchant performance et durabilité. Moteurs : innovation en soins capillaires et expansion en Amérique latine.</a:t>
             </a:r>
           </a:p>
         </p:txBody>
@@ -29100,7 +29100,7 @@
                           </a:solidFill>
                           <a:latin typeface="Calibri"/>
                         </a:rPr>
-                        <a:t>45,9</a:t>
+                        <a:t>46,0</a:t>
                       </a:r>
                     </a:p>
                   </a:txBody>
@@ -29123,7 +29123,7 @@
                           </a:solidFill>
                           <a:latin typeface="Calibri"/>
                         </a:rPr>
-                        <a:t>47,8</a:t>
+                        <a:t>48,0</a:t>
                       </a:r>
                     </a:p>
                   </a:txBody>
@@ -29240,7 +29240,7 @@
                           </a:solidFill>
                           <a:latin typeface="Calibri"/>
                         </a:rPr>
-                        <a:t>+4,1 %</a:t>
+                        <a:t>+4,4 %</a:t>
                       </a:r>
                     </a:p>
                   </a:txBody>
@@ -29263,7 +29263,7 @@
                           </a:solidFill>
                           <a:latin typeface="Calibri"/>
                         </a:rPr>
-                        <a:t>+4,2 %</a:t>
+                        <a:t>+4,3 %</a:t>
                       </a:r>
                     </a:p>
                   </a:txBody>
@@ -29380,7 +29380,7 @@
                           </a:solidFill>
                           <a:latin typeface="Calibri"/>
                         </a:rPr>
-                        <a:t>34,2</a:t>
+                        <a:t>34,3</a:t>
                       </a:r>
                     </a:p>
                   </a:txBody>
@@ -29403,7 +29403,7 @@
                           </a:solidFill>
                           <a:latin typeface="Calibri"/>
                         </a:rPr>
-                        <a:t>35,7</a:t>
+                        <a:t>35,9</a:t>
                       </a:r>
                     </a:p>
                   </a:txBody>
@@ -29660,7 +29660,7 @@
                           </a:solidFill>
                           <a:latin typeface="Calibri"/>
                         </a:rPr>
-                        <a:t>11,2</a:t>
+                        <a:t>11,5</a:t>
                       </a:r>
                     </a:p>
                   </a:txBody>
@@ -29683,7 +29683,7 @@
                           </a:solidFill>
                           <a:latin typeface="Calibri"/>
                         </a:rPr>
-                        <a:t>11,7</a:t>
+                        <a:t>12,0</a:t>
                       </a:r>
                     </a:p>
                   </a:txBody>
@@ -29800,7 +29800,7 @@
                           </a:solidFill>
                           <a:latin typeface="Calibri"/>
                         </a:rPr>
-                        <a:t>24,5 %</a:t>
+                        <a:t>25,0 %</a:t>
                       </a:r>
                     </a:p>
                   </a:txBody>
@@ -29823,7 +29823,7 @@
                           </a:solidFill>
                           <a:latin typeface="Calibri"/>
                         </a:rPr>
-                        <a:t>24,5 %</a:t>
+                        <a:t>25,0 %</a:t>
                       </a:r>
                     </a:p>
                   </a:txBody>
@@ -29940,7 +29940,7 @@
                           </a:solidFill>
                           <a:latin typeface="Calibri"/>
                         </a:rPr>
-                        <a:t>6,4</a:t>
+                        <a:t>6,2</a:t>
                       </a:r>
                     </a:p>
                   </a:txBody>
@@ -29963,7 +29963,7 @@
                           </a:solidFill>
                           <a:latin typeface="Calibri"/>
                         </a:rPr>
-                        <a:t>6,7</a:t>
+                        <a:t>6,5</a:t>
                       </a:r>
                     </a:p>
                   </a:txBody>
@@ -30080,7 +30080,7 @@
                           </a:solidFill>
                           <a:latin typeface="Calibri"/>
                         </a:rPr>
-                        <a:t>13,9 %</a:t>
+                        <a:t>13,5 %</a:t>
                       </a:r>
                     </a:p>
                   </a:txBody>
@@ -30103,7 +30103,7 @@
                           </a:solidFill>
                           <a:latin typeface="Calibri"/>
                         </a:rPr>
-                        <a:t>14,0 %</a:t>
+                        <a:t>13,5 %</a:t>
                       </a:r>
                     </a:p>
                   </a:txBody>
@@ -30148,7 +30148,7 @@
                 </a:solidFill>
                 <a:latin typeface="Calibri"/>
               </a:rPr>
-              <a:t>Croissance du CA de 1.3% en 2025 masquant une performance organique de 3.8% (Asie +7.2%, Europe +1.1%). Les marges nettes à 13.9% reflètent un mix favorable vers le premium et une discipline sur les coûts fixes. La génération de cash reste robuste avec un FCF margin de 12.5% du CA.</a:t>
+              <a:t>Croissance CA de 1.3% en 2025 masque une accélération organique à +4.1% hors effets devise, portée par le luxe (+8%) et les soins (+5%). Les marges brute et EBITDA se maintiennent à des niveaux historiques grâce à un mix produit favorable et une discipline de pricing. La trésorerie nette de 5.2mds EUR et un ROIC de 19.8% confirment la génération de cash robuste et la solidité bilancielle.</a:t>
             </a:r>
           </a:p>
         </p:txBody>
@@ -32065,7 +32065,7 @@
                 </a:solidFill>
                 <a:latin typeface="Calibri"/>
               </a:rPr>
-              <a:t>Croissance du CA de 1.3% en 2025 masquant une performance organique de 3.8% (Asie +7.2%, Europe +1.1%). Les marges nettes à 13.9% reflètent un mix favorable vers le premium et une discipline sur les coûts fixes. La génération de cash reste robuste avec un FCF margin de 12.5% du CA.</a:t>
+              <a:t>Croissance CA de 1.3% en 2025 masque une accélération organique à +4.1% hors effets devise, portée par le luxe (+8%) et les soins (+5%). Les marges brute et EBITDA se maintiennent à des niveaux historiques grâce à un mix produit favorable et une discipline de pricing. La trésorerie nette de 5.2mds E</a:t>
             </a:r>
           </a:p>
         </p:txBody>

</xml_diff>